<commit_message>
powerpoint skills and report
</commit_message>
<xml_diff>
--- a/codeme/skills/qarag-pptx-reporter-skill-assets/QA_Delivery_Health_Status_Report_Template_-_Optimized.pptx
+++ b/codeme/skills/qarag-pptx-reporter-skill-assets/QA_Delivery_Health_Status_Report_Template_-_Optimized.pptx
@@ -9,6 +9,7 @@
     <p:sldId id="267" r:id="rId3"/>
     <p:sldId id="266" r:id="rId4"/>
     <p:sldId id="264" r:id="rId5"/>
+    <p:sldId id="268" r:id="rId6"/>
   </p:sldIdLst>
   <p:sldSz cx="12192000" cy="6858000"/>
   <p:notesSz cx="6858000" cy="9144000"/>
@@ -1276,7 +1277,7 @@
                   <a:srgbClr val="FFFFFF"/>
                 </a:solidFill>
               </a:rPr>
-              <a:t>[Project Name]</a:t>
+              <a:t>Atlas Delivery Platform</a:t>
             </a:r>
             <a:endParaRPr sz="2800" b="1" dirty="0">
               <a:solidFill>
@@ -1328,7 +1329,7 @@
                   <a:srgbClr val="C8C8D0"/>
                 </a:solidFill>
               </a:rPr>
-              <a:t>[Reporting Period]</a:t>
+              <a:t>July 2026</a:t>
             </a:r>
             <a:r>
               <a:rPr sz="1400" dirty="0">
@@ -1376,7 +1377,7 @@
                   <a:srgbClr val="C8C8D0"/>
                 </a:solidFill>
               </a:rPr>
-              <a:t>[last report time] |   Author: [user.name]</a:t>
+              <a:t>2026-08-01 09:00 UTC |   Author: Volodymyr</a:t>
             </a:r>
             <a:endParaRPr sz="1400" dirty="0">
               <a:solidFill>
@@ -1576,7 +1577,7 @@
                   <a:srgbClr val="FFFFFF"/>
                 </a:solidFill>
               </a:rPr>
-              <a:t>Score: [n.nn] / 3</a:t>
+              <a:t>Score: 2.13 / 3</a:t>
             </a:r>
           </a:p>
         </p:txBody>
@@ -1618,9 +1619,34 @@
             </a:pPr>
             <a:r>
               <a:rPr lang="en-US" sz="1200" dirty="0"/>
-              <a:t>[General conclusions about project status]</a:t>
-            </a:r>
-            <a:endParaRPr sz="1200" dirty="0"/>
+              <a:t>Overall status is AMBER.</a:t>
+            </a:r>
+          </a:p>
+          <a:p>
+            <a:pPr algn="ctr">
+              <a:defRPr sz="1200">
+                <a:solidFill>
+                  <a:srgbClr val="FFFFFF"/>
+                </a:solidFill>
+              </a:defRPr>
+            </a:pPr>
+            <a:r>
+              <a:rPr lang="en-US" sz="1200" dirty="0"/>
+              <a:t>Proceeding to release requires a short-term plan to reduce critical defect load and close P1/P2 execution gaps.</a:t>
+            </a:r>
+          </a:p>
+          <a:p>
+            <a:pPr algn="ctr">
+              <a:defRPr sz="1200">
+                <a:solidFill>
+                  <a:srgbClr val="FFFFFF"/>
+                </a:solidFill>
+              </a:defRPr>
+            </a:pPr>
+            <a:r>
+              <a:rPr lang="en-US" sz="1200" dirty="0"/>
+              <a:t>QA capacity constraints must be addressed to prevent late-cycle validation risks.</a:t>
+            </a:r>
           </a:p>
         </p:txBody>
       </p:sp>
@@ -1698,7 +1724,7 @@
                   <a:srgbClr val="0B0B0F"/>
                 </a:solidFill>
               </a:rPr>
-              <a:t>[RAG STATUS]</a:t>
+              <a:t>AMBER</a:t>
             </a:r>
             <a:endParaRPr sz="3500" b="1" dirty="0">
               <a:solidFill>
@@ -1882,7 +1908,7 @@
                   <a:srgbClr val="C8C8D0"/>
                 </a:solidFill>
               </a:rPr>
-              <a:t>[Project entry information]</a:t>
+              <a:t>Cadence: Monthly | Dev: 10 | QA: 2 | Jira connected: No</a:t>
             </a:r>
           </a:p>
           <a:p>
@@ -1892,7 +1918,7 @@
                   <a:srgbClr val="C8C8D0"/>
                 </a:solidFill>
               </a:rPr>
-              <a:t>[Metrics types in scope]</a:t>
+              <a:t>Ongoing/Efficiency</a:t>
             </a:r>
             <a:endParaRPr sz="1200" dirty="0">
               <a:solidFill>
@@ -1902,6 +1928,30 @@
           </a:p>
         </p:txBody>
       </p:sp>
+      <p:pic>
+        <p:nvPicPr>
+          <p:cNvPr id="44" name="Picture 44" descr="[Rose Chart for Project Group Metrics Statuses]"/>
+          <p:cNvPicPr>
+            <a:picLocks noChangeAspect="1"/>
+          </p:cNvPicPr>
+          <p:nvPr/>
+        </p:nvPicPr>
+        <p:blipFill>
+          <a:blip r:embed="rId2"/>
+          <a:stretch>
+            <a:fillRect/>
+          </a:stretch>
+        </p:blipFill>
+        <p:spPr>
+          <a:xfrm>
+            <a:off x="7246213" y="1788098"/>
+            <a:ext cx="4424169" cy="4424169"/>
+          </a:xfrm>
+          <a:prstGeom prst="rect">
+            <a:avLst/>
+          </a:prstGeom>
+        </p:spPr>
+      </p:pic>
     </p:spTree>
     <p:extLst>
       <p:ext uri="{BB962C8B-B14F-4D97-AF65-F5344CB8AC3E}">
@@ -2044,13 +2094,13 @@
       </p:sp>
       <p:sp>
         <p:nvSpPr>
-          <p:cNvPr id="101" name="Category Card 1" descr="Category Card"/>
+          <p:cNvPr id="200" name="Category Card" descr="Category Card"/>
           <p:cNvSpPr/>
           <p:nvPr/>
         </p:nvSpPr>
         <p:spPr>
           <a:xfrm>
-            <a:off x="833238" y="2162009"/>
+            <a:off x="789800" y="2162009"/>
             <a:ext cx="5053523" cy="3032113"/>
           </a:xfrm>
           <a:prstGeom prst="rect">
@@ -2091,7 +2141,7 @@
                   <a:srgbClr val="55E66F"/>
                 </a:solidFill>
               </a:rPr>
-              <a:t>[Group Metric 1]  ([n.nn]/3, [RAG STATUS])</a:t>
+              <a:t>Testing Delivery Status  (2.33/3, GREEN)</a:t>
             </a:r>
           </a:p>
           <a:p>
@@ -2113,20 +2163,20 @@
                   <a:srgbClr val="FFFFFF"/>
                 </a:solidFill>
               </a:rPr>
-              <a:t>[Group Metric 1 General Conclusion]</a:t>
-            </a:r>
-          </a:p>
-        </p:txBody>
-      </p:sp>
-      <p:sp>
-        <p:nvSpPr>
-          <p:cNvPr id="102" name="Category Card 2" descr="Category Card"/>
+              <a:t>Delivery cadence is on track; primary risk is thin QA capacity relative to dev team size.</a:t>
+            </a:r>
+          </a:p>
+        </p:txBody>
+      </p:sp>
+      <p:sp>
+        <p:nvSpPr>
+          <p:cNvPr id="201" name="Category Card" descr="Category Card"/>
           <p:cNvSpPr/>
           <p:nvPr/>
         </p:nvSpPr>
         <p:spPr>
           <a:xfrm>
-            <a:off x="6392114" y="2162009"/>
+            <a:off x="6348676" y="2162009"/>
             <a:ext cx="5053523" cy="3032113"/>
           </a:xfrm>
           <a:prstGeom prst="rect">
@@ -2164,10 +2214,10 @@
             <a:r>
               <a:rPr lang="en-US" sz="3400" b="1" kern="1200" dirty="0">
                 <a:solidFill>
-                  <a:srgbClr val="55E66F"/>
-                </a:solidFill>
-              </a:rPr>
-              <a:t>[Group Metric N]  ([n.nn]/3, [RAG STATUS])</a:t>
+                  <a:srgbClr val="FF7701"/>
+                </a:solidFill>
+              </a:rPr>
+              <a:t>Release Readiness  (1.92/3, AMBER)</a:t>
             </a:r>
           </a:p>
           <a:p>
@@ -2189,7 +2239,7 @@
                   <a:srgbClr val="FFFFFF"/>
                 </a:solidFill>
               </a:rPr>
-              <a:t>[Group Metric N General Conclusion]</a:t>
+              <a:t>Open P1/P2 defect load and incomplete manual execution coverage are the main blockers to release readiness.</a:t>
             </a:r>
           </a:p>
         </p:txBody>
@@ -2236,7 +2286,7 @@
                   <a:srgbClr val="C8C8D0"/>
                 </a:solidFill>
               </a:rPr>
-              <a:t>[Reporting Period]</a:t>
+              <a:t>July 2026</a:t>
             </a:r>
             <a:r>
               <a:rPr sz="1400" dirty="0">
@@ -2284,7 +2334,7 @@
                   <a:srgbClr val="C8C8D0"/>
                 </a:solidFill>
               </a:rPr>
-              <a:t>[last report time] |   Author: [user.name]</a:t>
+              <a:t>2026-08-01 09:00 UTC |   Author: Volodymyr</a:t>
             </a:r>
             <a:endParaRPr sz="1400" dirty="0">
               <a:solidFill>
@@ -2553,7 +2603,7 @@
                 </a:solidFill>
                 <a:latin typeface="Arial"/>
               </a:rPr>
-              <a:t>1. [TOP_RED_1_GROUP] — [TOP_RED_1_ITEM] (Why: [TOP_RED_1_WHY])</a:t>
+              <a:t>1. Release Readiness — P1/P2 defects (Why: P1=1, P2=10 open)</a:t>
             </a:r>
           </a:p>
           <a:p>
@@ -2565,7 +2615,7 @@
                 </a:solidFill>
                 <a:latin typeface="Arial"/>
               </a:rPr>
-              <a:t>   Action: [TOP_RED_1_ACTION]</a:t>
+              <a:t>   Action: Run a focused P1/P2 burn-down before release</a:t>
             </a:r>
           </a:p>
           <a:p>
@@ -2576,7 +2626,7 @@
                 </a:solidFill>
                 <a:latin typeface="Arial"/>
               </a:rPr>
-              <a:t>2. [TOP_RED_2_GROUP] — [TOP_RED_2_ITEM] (Why: [TOP_RED_2_WHY])</a:t>
+              <a:t>2. Release Readiness — Manual P1/P2 execution coverage (Why: Finished at 80%)</a:t>
             </a:r>
           </a:p>
           <a:p>
@@ -2587,7 +2637,7 @@
                 </a:solidFill>
                 <a:latin typeface="Arial"/>
               </a:rPr>
-              <a:t>   Action: [TOP_RED_2_ACTION]</a:t>
+              <a:t>   Action: Execute remaining P1/P2 tests or formally de-scope with explicit sign-off</a:t>
             </a:r>
           </a:p>
           <a:p>
@@ -2598,7 +2648,7 @@
                 </a:solidFill>
                 <a:latin typeface="Arial"/>
               </a:rPr>
-              <a:t>3. [TOP_RED_3_GROUP] — [TOP_RED_3_ITEM] (Why: [TOP_RED_3_WHY])</a:t>
+              <a:t>3. Testing Delivery Status — QA capacity (Why: Dev:QA 15:1 (QA share ~6.3%))</a:t>
             </a:r>
           </a:p>
           <a:p>
@@ -2609,51 +2659,7 @@
                 </a:solidFill>
                 <a:latin typeface="Arial"/>
               </a:rPr>
-              <a:t>   Action: [TOP_RED_3_ACTION]</a:t>
-            </a:r>
-          </a:p>
-          <a:p>
-            <a:r>
-              <a:rPr sz="1200" b="0" dirty="0">
-                <a:solidFill>
-                  <a:srgbClr val="FFFFFF"/>
-                </a:solidFill>
-                <a:latin typeface="Arial"/>
-              </a:rPr>
-              <a:t>4. [TOP_RED_4_GROUP] — [TOP_RED_4_ITEM] (Why: [TOP_RED_4_WHY])</a:t>
-            </a:r>
-          </a:p>
-          <a:p>
-            <a:r>
-              <a:rPr sz="1200" b="0" dirty="0">
-                <a:solidFill>
-                  <a:srgbClr val="FFFFFF"/>
-                </a:solidFill>
-                <a:latin typeface="Arial"/>
-              </a:rPr>
-              <a:t>   Action: [TOP_RED_4_ACTION]</a:t>
-            </a:r>
-          </a:p>
-          <a:p>
-            <a:r>
-              <a:rPr sz="1200" b="0" dirty="0">
-                <a:solidFill>
-                  <a:srgbClr val="FFFFFF"/>
-                </a:solidFill>
-                <a:latin typeface="Arial"/>
-              </a:rPr>
-              <a:t>5. [TOP_RED_5_GROUP] — [TOP_RED_5_ITEM] (Why: [TOP_RED_5_WHY])</a:t>
-            </a:r>
-          </a:p>
-          <a:p>
-            <a:r>
-              <a:rPr sz="1200" b="0" dirty="0">
-                <a:solidFill>
-                  <a:srgbClr val="FFFFFF"/>
-                </a:solidFill>
-                <a:latin typeface="Arial"/>
-              </a:rPr>
-              <a:t>   Action: [TOP_RED_5_ACTION]</a:t>
+              <a:t>   Action: Add QA capacity and/or reduce scope; push shift-left testing</a:t>
             </a:r>
           </a:p>
         </p:txBody>
@@ -2745,7 +2751,7 @@
                 </a:solidFill>
                 <a:latin typeface="Arial"/>
               </a:rPr>
-              <a:t>1. [TOP_AMBER_1_GROUP] — [TOP_AMBER_1_ITEM] (Why: [TOP_AMBER_1_WHY])</a:t>
+              <a:t>1. Release Readiness — P3+ defects (Why: 13 open)</a:t>
             </a:r>
           </a:p>
           <a:p>
@@ -2756,7 +2762,7 @@
                 </a:solidFill>
                 <a:latin typeface="Arial"/>
               </a:rPr>
-              <a:t>   Action: [TOP_AMBER_1_ACTION]</a:t>
+              <a:t>   Action: Triage/groom to keep backlog ≤ 10</a:t>
             </a:r>
           </a:p>
           <a:p>
@@ -2767,7 +2773,7 @@
                 </a:solidFill>
                 <a:latin typeface="Arial"/>
               </a:rPr>
-              <a:t>2. [TOP_AMBER_2_GROUP] — [TOP_AMBER_2_ITEM] (Why: [TOP_AMBER_2_WHY])</a:t>
+              <a:t>2. Release Readiness — Automated P1/P2 execution coverage (Why: 90%)</a:t>
             </a:r>
           </a:p>
           <a:p>
@@ -2778,73 +2784,7 @@
                 </a:solidFill>
                 <a:latin typeface="Arial"/>
               </a:rPr>
-              <a:t>   Action: [TOP_AMBER_2_ACTION]</a:t>
-            </a:r>
-          </a:p>
-          <a:p>
-            <a:r>
-              <a:rPr lang="en-US" sz="1200" dirty="0">
-                <a:solidFill>
-                  <a:srgbClr val="FFFFFF"/>
-                </a:solidFill>
-                <a:latin typeface="Arial"/>
-              </a:rPr>
-              <a:t>3. [TOP_AMBER_3_GROUP] — [TOP_AMBER_3_ITEM] (Why: [TOP_AMBER_3_WHY])</a:t>
-            </a:r>
-          </a:p>
-          <a:p>
-            <a:r>
-              <a:rPr lang="en-US" sz="1200" dirty="0">
-                <a:solidFill>
-                  <a:srgbClr val="FFFFFF"/>
-                </a:solidFill>
-                <a:latin typeface="Arial"/>
-              </a:rPr>
-              <a:t>   Action: [TOP_AMBER_3_ACTION]</a:t>
-            </a:r>
-          </a:p>
-          <a:p>
-            <a:r>
-              <a:rPr lang="en-US" sz="1200" dirty="0">
-                <a:solidFill>
-                  <a:srgbClr val="FFFFFF"/>
-                </a:solidFill>
-                <a:latin typeface="Arial"/>
-              </a:rPr>
-              <a:t>4. [TOP_AMBER_4_GROUP] — [TOP_AMBER_4_ITEM] (Why: [TOP_AMBER_4_WHY])</a:t>
-            </a:r>
-          </a:p>
-          <a:p>
-            <a:r>
-              <a:rPr lang="en-US" sz="1200" dirty="0">
-                <a:solidFill>
-                  <a:srgbClr val="FFFFFF"/>
-                </a:solidFill>
-                <a:latin typeface="Arial"/>
-              </a:rPr>
-              <a:t>   Action: [TOP_AMBER_4_ACTION]</a:t>
-            </a:r>
-          </a:p>
-          <a:p>
-            <a:r>
-              <a:rPr lang="en-US" sz="1200" dirty="0">
-                <a:solidFill>
-                  <a:srgbClr val="FFFFFF"/>
-                </a:solidFill>
-                <a:latin typeface="Arial"/>
-              </a:rPr>
-              <a:t>5. [TOP_AMBER_5_GROUP] — [TOP_AMBER_5_ITEM] (Why: [TOP_AMBER_5_WHY])</a:t>
-            </a:r>
-          </a:p>
-          <a:p>
-            <a:r>
-              <a:rPr lang="en-US" sz="1200" dirty="0">
-                <a:solidFill>
-                  <a:srgbClr val="FFFFFF"/>
-                </a:solidFill>
-                <a:latin typeface="Arial"/>
-              </a:rPr>
-              <a:t>   Action: [TOP_AMBER_5_ACTION]</a:t>
+              <a:t>   Action: Stabilize/fix missing automation to reach 100%</a:t>
             </a:r>
           </a:p>
         </p:txBody>
@@ -2997,7 +2937,7 @@
                   <a:srgbClr val="C8C8D0"/>
                 </a:solidFill>
               </a:rPr>
-              <a:t>[Reporting Period]</a:t>
+              <a:t>July 2026</a:t>
             </a:r>
             <a:r>
               <a:rPr sz="1400" dirty="0">
@@ -3045,7 +2985,7 @@
                   <a:srgbClr val="C8C8D0"/>
                 </a:solidFill>
               </a:rPr>
-              <a:t>[last report time] |   Author: [user.name]</a:t>
+              <a:t>2026-08-01 09:00 UTC |   Author: Volodymyr</a:t>
             </a:r>
             <a:endParaRPr sz="1400" dirty="0">
               <a:solidFill>
@@ -3232,7 +3172,7 @@
                   <a:srgbClr val="FFFFFF"/>
                 </a:solidFill>
               </a:rPr>
-              <a:t>G[N]</a:t>
+              <a:t>G1</a:t>
             </a:r>
             <a:r>
               <a:rPr sz="2800" b="1" dirty="0">
@@ -3248,7 +3188,7 @@
                   <a:srgbClr val="FFFFFF"/>
                 </a:solidFill>
               </a:rPr>
-              <a:t>[Group Metric name N]</a:t>
+              <a:t>Testing Delivery Status</a:t>
             </a:r>
             <a:endParaRPr sz="2800" b="1" dirty="0">
               <a:solidFill>
@@ -3292,7 +3232,7 @@
                   <a:srgbClr val="C8C8D0"/>
                 </a:solidFill>
               </a:rPr>
-              <a:t>Score: [n.nn] / 3   |   RAG: [RAG STATUS]</a:t>
+              <a:t>Score: 2.33 / 3   |   RAG: GREEN</a:t>
             </a:r>
           </a:p>
         </p:txBody>
@@ -3384,7 +3324,7 @@
                   <a:srgbClr val="0B0B0F"/>
                 </a:solidFill>
               </a:rPr>
-              <a:t>[RAG Status]</a:t>
+              <a:t>GREEN</a:t>
             </a:r>
             <a:endParaRPr sz="1600" b="1" dirty="0">
               <a:solidFill>
@@ -3529,9 +3469,8 @@
             </a:pPr>
             <a:r>
               <a:rPr lang="en-US" dirty="0"/>
-              <a:t>[List of RED Findings with some recommendations]</a:t>
-            </a:r>
-            <a:endParaRPr dirty="0"/>
+              <a:t>QA capacity: Dev:QA 15:1 (QA share ~6.3%) — add capacity and/or reduce scope; push shift-left testing</a:t>
+            </a:r>
           </a:p>
         </p:txBody>
       </p:sp>
@@ -3624,7 +3563,7 @@
             </a:pPr>
             <a:r>
               <a:rPr lang="en-US" dirty="0"/>
-              <a:t>[General Conclusion on this metrics category and key recommendations] </a:t>
+              <a:t>Delivery cadence is on track; primary risk is thin QA capacity relative to dev team size.</a:t>
             </a:r>
             <a:endParaRPr dirty="0"/>
           </a:p>
@@ -3767,7 +3706,7 @@
             </a:pPr>
             <a:r>
               <a:rPr lang="en-US" dirty="0"/>
-              <a:t>[List of AMBER Findings with some recommendations]</a:t>
+              <a:t>—</a:t>
             </a:r>
           </a:p>
         </p:txBody>
@@ -3918,7 +3857,7 @@
                             <a:srgbClr val="FFFFFF"/>
                           </a:solidFill>
                         </a:rPr>
-                        <a:t>[Key data name 1]</a:t>
+                        <a:t>Dev:QA ratio</a:t>
                       </a:r>
                       <a:endParaRPr sz="1100" dirty="0">
                         <a:solidFill>
@@ -3944,7 +3883,7 @@
                             <a:srgbClr val="FFFFFF"/>
                           </a:solidFill>
                         </a:rPr>
-                        <a:t>[Key data name 1]</a:t>
+                        <a:t>15:1 (QA share ~6.3%)</a:t>
                       </a:r>
                       <a:endParaRPr sz="1100" dirty="0">
                         <a:solidFill>
@@ -3977,7 +3916,7 @@
                             <a:srgbClr val="FFFFFF"/>
                           </a:solidFill>
                         </a:rPr>
-                        <a:t>[Key data name N]</a:t>
+                        <a:t>—</a:t>
                       </a:r>
                       <a:endParaRPr sz="1100" dirty="0">
                         <a:solidFill>
@@ -4003,7 +3942,7 @@
                             <a:srgbClr val="FFFFFF"/>
                           </a:solidFill>
                         </a:rPr>
-                        <a:t>[Key data name N]</a:t>
+                        <a:t>—</a:t>
                       </a:r>
                       <a:endParaRPr sz="1100" dirty="0">
                         <a:solidFill>
@@ -4053,7 +3992,7 @@
                             <a:srgbClr val="FFFFFF"/>
                           </a:solidFill>
                         </a:rPr>
-                        <a:t>[Key data name N+1]</a:t>
+                        <a:t>—</a:t>
                       </a:r>
                     </a:p>
                     <a:p>
@@ -4098,7 +4037,7 @@
                             <a:srgbClr val="FFFFFF"/>
                           </a:solidFill>
                         </a:rPr>
-                        <a:t>[Key data name N+1]</a:t>
+                        <a:t>—</a:t>
                       </a:r>
                     </a:p>
                   </a:txBody>
@@ -4143,7 +4082,7 @@
                             <a:srgbClr val="FFFFFF"/>
                           </a:solidFill>
                         </a:rPr>
-                        <a:t>[Key data name N+2]</a:t>
+                        <a:t>—</a:t>
                       </a:r>
                     </a:p>
                   </a:txBody>
@@ -4181,7 +4120,1183 @@
                             <a:srgbClr val="FFFFFF"/>
                           </a:solidFill>
                         </a:rPr>
-                        <a:t>[Key data name N+2]</a:t>
+                        <a:t>—</a:t>
+                      </a:r>
+                    </a:p>
+                  </a:txBody>
+                  <a:tcPr>
+                    <a:solidFill>
+                      <a:srgbClr val="16161F"/>
+                    </a:solidFill>
+                  </a:tcPr>
+                </a:tc>
+                <a:extLst>
+                  <a:ext uri="{0D108BD9-81ED-4DB2-BD59-A6C34878D82A}">
+                    <a16:rowId xmlns:a16="http://schemas.microsoft.com/office/drawing/2014/main" val="10004"/>
+                  </a:ext>
+                </a:extLst>
+              </a:tr>
+            </a:tbl>
+          </a:graphicData>
+        </a:graphic>
+      </p:graphicFrame>
+    </p:spTree>
+    <p:extLst>
+      <p:ext uri="{BB962C8B-B14F-4D97-AF65-F5344CB8AC3E}">
+        <p14:creationId xmlns:p14="http://schemas.microsoft.com/office/powerpoint/2010/main" val="693321489"/>
+      </p:ext>
+    </p:extLst>
+  </p:cSld>
+  <p:clrMapOvr>
+    <a:masterClrMapping/>
+  </p:clrMapOvr>
+</p:sld>
+</file>
+
+<file path=ppt/slides/slide5.xml><?xml version="1.0" encoding="utf-8"?>
+<p:sld xmlns:a="http://schemas.openxmlformats.org/drawingml/2006/main" xmlns:r="http://schemas.openxmlformats.org/officeDocument/2006/relationships" xmlns:p="http://schemas.openxmlformats.org/presentationml/2006/main">
+  <p:cSld>
+    <p:bg>
+      <p:bgPr>
+        <a:solidFill>
+          <a:srgbClr val="0B0B0F"/>
+        </a:solidFill>
+        <a:effectLst/>
+      </p:bgPr>
+    </p:bg>
+    <p:spTree>
+      <p:nvGrpSpPr>
+        <p:cNvPr id="1" name="">
+          <a:extLst>
+            <a:ext uri="{FF2B5EF4-FFF2-40B4-BE49-F238E27FC236}">
+              <a16:creationId xmlns:a16="http://schemas.microsoft.com/office/drawing/2014/main" id="{5AB14D6E-FDFE-AEB9-3E7B-647E6EE7691F}"/>
+            </a:ext>
+          </a:extLst>
+        </p:cNvPr>
+        <p:cNvGrpSpPr/>
+        <p:nvPr/>
+      </p:nvGrpSpPr>
+      <p:grpSpPr>
+        <a:xfrm>
+          <a:off x="0" y="0"/>
+          <a:ext cx="0" cy="0"/>
+          <a:chOff x="0" y="0"/>
+          <a:chExt cx="0" cy="0"/>
+        </a:xfrm>
+      </p:grpSpPr>
+      <p:sp>
+        <p:nvSpPr>
+          <p:cNvPr id="18" name="Rectangle 17">
+            <a:extLst>
+              <a:ext uri="{FF2B5EF4-FFF2-40B4-BE49-F238E27FC236}">
+                <a16:creationId xmlns:a16="http://schemas.microsoft.com/office/drawing/2014/main" id="{2A82E1EF-2CCD-604A-FB49-FD9A7969C04A}"/>
+              </a:ext>
+            </a:extLst>
+          </p:cNvPr>
+          <p:cNvSpPr/>
+          <p:nvPr/>
+        </p:nvSpPr>
+        <p:spPr>
+          <a:xfrm>
+            <a:off x="548640" y="1417320"/>
+            <a:ext cx="5394960" cy="2377440"/>
+          </a:xfrm>
+          <a:prstGeom prst="rect">
+            <a:avLst/>
+          </a:prstGeom>
+          <a:solidFill>
+            <a:srgbClr val="16161F"/>
+          </a:solidFill>
+          <a:ln w="12700">
+            <a:solidFill>
+              <a:srgbClr val="2A2A38"/>
+            </a:solidFill>
+          </a:ln>
+        </p:spPr>
+        <p:style>
+          <a:lnRef idx="1">
+            <a:schemeClr val="accent1"/>
+          </a:lnRef>
+          <a:fillRef idx="3">
+            <a:schemeClr val="accent1"/>
+          </a:fillRef>
+          <a:effectRef idx="2">
+            <a:schemeClr val="accent1"/>
+          </a:effectRef>
+          <a:fontRef idx="minor">
+            <a:schemeClr val="lt1"/>
+          </a:fontRef>
+        </p:style>
+        <p:txBody>
+          <a:bodyPr rtlCol="0" anchor="ctr"/>
+          <a:lstStyle/>
+          <a:p>
+            <a:pPr algn="ctr"/>
+            <a:endParaRPr/>
+          </a:p>
+        </p:txBody>
+      </p:sp>
+      <p:sp>
+        <p:nvSpPr>
+          <p:cNvPr id="12" name="Rectangle 11">
+            <a:extLst>
+              <a:ext uri="{FF2B5EF4-FFF2-40B4-BE49-F238E27FC236}">
+                <a16:creationId xmlns:a16="http://schemas.microsoft.com/office/drawing/2014/main" id="{D9E3F4AC-DE7B-F8CE-132B-9C412219AA7E}"/>
+              </a:ext>
+            </a:extLst>
+          </p:cNvPr>
+          <p:cNvSpPr/>
+          <p:nvPr/>
+        </p:nvSpPr>
+        <p:spPr>
+          <a:xfrm>
+            <a:off x="548640" y="3977639"/>
+            <a:ext cx="5394960" cy="2560320"/>
+          </a:xfrm>
+          <a:prstGeom prst="rect">
+            <a:avLst/>
+          </a:prstGeom>
+          <a:solidFill>
+            <a:srgbClr val="16161F"/>
+          </a:solidFill>
+          <a:ln w="12700">
+            <a:solidFill>
+              <a:srgbClr val="2A2A38"/>
+            </a:solidFill>
+          </a:ln>
+        </p:spPr>
+        <p:style>
+          <a:lnRef idx="1">
+            <a:schemeClr val="accent1"/>
+          </a:lnRef>
+          <a:fillRef idx="3">
+            <a:schemeClr val="accent1"/>
+          </a:fillRef>
+          <a:effectRef idx="2">
+            <a:schemeClr val="accent1"/>
+          </a:effectRef>
+          <a:fontRef idx="minor">
+            <a:schemeClr val="lt1"/>
+          </a:fontRef>
+        </p:style>
+        <p:txBody>
+          <a:bodyPr rtlCol="0" anchor="ctr"/>
+          <a:lstStyle/>
+          <a:p>
+            <a:pPr algn="ctr"/>
+            <a:endParaRPr/>
+          </a:p>
+        </p:txBody>
+      </p:sp>
+      <p:sp>
+        <p:nvSpPr>
+          <p:cNvPr id="2" name="TextBox 1">
+            <a:extLst>
+              <a:ext uri="{FF2B5EF4-FFF2-40B4-BE49-F238E27FC236}">
+                <a16:creationId xmlns:a16="http://schemas.microsoft.com/office/drawing/2014/main" id="{C68B28B5-4720-8F0C-479C-F81F7225D744}"/>
+              </a:ext>
+            </a:extLst>
+          </p:cNvPr>
+          <p:cNvSpPr txBox="1"/>
+          <p:nvPr/>
+        </p:nvSpPr>
+        <p:spPr>
+          <a:xfrm>
+            <a:off x="548640" y="320040"/>
+            <a:ext cx="4849020" cy="523220"/>
+          </a:xfrm>
+          <a:prstGeom prst="rect">
+            <a:avLst/>
+          </a:prstGeom>
+          <a:noFill/>
+        </p:spPr>
+        <p:txBody>
+          <a:bodyPr wrap="none">
+            <a:spAutoFit/>
+          </a:bodyPr>
+          <a:lstStyle/>
+          <a:p>
+            <a:r>
+              <a:rPr lang="en-US" sz="2800" b="1" dirty="0">
+                <a:solidFill>
+                  <a:srgbClr val="FFFFFF"/>
+                </a:solidFill>
+              </a:rPr>
+              <a:t>G2</a:t>
+            </a:r>
+            <a:r>
+              <a:rPr sz="2800" b="1" dirty="0">
+                <a:solidFill>
+                  <a:srgbClr val="FFFFFF"/>
+                </a:solidFill>
+              </a:rPr>
+              <a:t> — </a:t>
+            </a:r>
+            <a:r>
+              <a:rPr lang="en-US" sz="2800" b="1" dirty="0">
+                <a:solidFill>
+                  <a:srgbClr val="FFFFFF"/>
+                </a:solidFill>
+              </a:rPr>
+              <a:t>Release Readiness</a:t>
+            </a:r>
+            <a:endParaRPr sz="2800" b="1" dirty="0">
+              <a:solidFill>
+                <a:srgbClr val="FFFFFF"/>
+              </a:solidFill>
+            </a:endParaRPr>
+          </a:p>
+        </p:txBody>
+      </p:sp>
+      <p:sp>
+        <p:nvSpPr>
+          <p:cNvPr id="3" name="TextBox 2">
+            <a:extLst>
+              <a:ext uri="{FF2B5EF4-FFF2-40B4-BE49-F238E27FC236}">
+                <a16:creationId xmlns:a16="http://schemas.microsoft.com/office/drawing/2014/main" id="{C8BDA4A0-1607-8B4A-F5BB-3FE26F3F6F53}"/>
+              </a:ext>
+            </a:extLst>
+          </p:cNvPr>
+          <p:cNvSpPr txBox="1"/>
+          <p:nvPr/>
+        </p:nvSpPr>
+        <p:spPr>
+          <a:xfrm>
+            <a:off x="548640" y="960120"/>
+            <a:ext cx="3071097" cy="307777"/>
+          </a:xfrm>
+          <a:prstGeom prst="rect">
+            <a:avLst/>
+          </a:prstGeom>
+          <a:noFill/>
+        </p:spPr>
+        <p:txBody>
+          <a:bodyPr wrap="none">
+            <a:spAutoFit/>
+          </a:bodyPr>
+          <a:lstStyle/>
+          <a:p>
+            <a:r>
+              <a:rPr sz="1400" dirty="0">
+                <a:solidFill>
+                  <a:srgbClr val="C8C8D0"/>
+                </a:solidFill>
+              </a:rPr>
+              <a:t>Score: 1.92 / 3   |   RAG: AMBER</a:t>
+            </a:r>
+          </a:p>
+        </p:txBody>
+      </p:sp>
+      <p:sp>
+        <p:nvSpPr>
+          <p:cNvPr id="4" name="Rectangle 3" descr="RAG Status Box">
+            <a:extLst>
+              <a:ext uri="{FF2B5EF4-FFF2-40B4-BE49-F238E27FC236}">
+                <a16:creationId xmlns:a16="http://schemas.microsoft.com/office/drawing/2014/main" id="{0BB17645-CC5B-ADB8-ED90-23DE2C861C01}"/>
+              </a:ext>
+            </a:extLst>
+          </p:cNvPr>
+          <p:cNvSpPr/>
+          <p:nvPr/>
+        </p:nvSpPr>
+        <p:spPr>
+          <a:xfrm>
+            <a:off x="10152110" y="389279"/>
+            <a:ext cx="1463040" cy="457200"/>
+          </a:xfrm>
+          <a:prstGeom prst="rect">
+            <a:avLst/>
+          </a:prstGeom>
+          <a:solidFill>
+            <a:srgbClr val="FF7701"/>
+          </a:solidFill>
+          <a:ln>
+            <a:solidFill>
+              <a:srgbClr val="55E66F"/>
+            </a:solidFill>
+          </a:ln>
+        </p:spPr>
+        <p:style>
+          <a:lnRef idx="1">
+            <a:schemeClr val="accent1"/>
+          </a:lnRef>
+          <a:fillRef idx="3">
+            <a:schemeClr val="accent1"/>
+          </a:fillRef>
+          <a:effectRef idx="2">
+            <a:schemeClr val="accent1"/>
+          </a:effectRef>
+          <a:fontRef idx="minor">
+            <a:schemeClr val="lt1"/>
+          </a:fontRef>
+        </p:style>
+        <p:txBody>
+          <a:bodyPr rtlCol="0" anchor="ctr"/>
+          <a:lstStyle/>
+          <a:p>
+            <a:pPr algn="ctr"/>
+            <a:endParaRPr/>
+          </a:p>
+        </p:txBody>
+      </p:sp>
+      <p:sp>
+        <p:nvSpPr>
+          <p:cNvPr id="5" name="TextBox 4">
+            <a:extLst>
+              <a:ext uri="{FF2B5EF4-FFF2-40B4-BE49-F238E27FC236}">
+                <a16:creationId xmlns:a16="http://schemas.microsoft.com/office/drawing/2014/main" id="{4DD24A98-8F05-1A04-2978-35EE4293E2A0}"/>
+              </a:ext>
+            </a:extLst>
+          </p:cNvPr>
+          <p:cNvSpPr txBox="1"/>
+          <p:nvPr/>
+        </p:nvSpPr>
+        <p:spPr>
+          <a:xfrm>
+            <a:off x="10284885" y="457010"/>
+            <a:ext cx="1263487" cy="338554"/>
+          </a:xfrm>
+          <a:prstGeom prst="rect">
+            <a:avLst/>
+          </a:prstGeom>
+          <a:noFill/>
+        </p:spPr>
+        <p:txBody>
+          <a:bodyPr wrap="none">
+            <a:spAutoFit/>
+          </a:bodyPr>
+          <a:lstStyle/>
+          <a:p>
+            <a:pPr algn="ctr"/>
+            <a:r>
+              <a:rPr lang="en-US" sz="1600" b="1" dirty="0">
+                <a:solidFill>
+                  <a:srgbClr val="0B0B0F"/>
+                </a:solidFill>
+              </a:rPr>
+              <a:t>AMBER</a:t>
+            </a:r>
+            <a:endParaRPr sz="1600" b="1" dirty="0">
+              <a:solidFill>
+                <a:srgbClr val="0B0B0F"/>
+              </a:solidFill>
+            </a:endParaRPr>
+          </a:p>
+        </p:txBody>
+      </p:sp>
+      <p:sp>
+        <p:nvSpPr>
+          <p:cNvPr id="9" name="Rectangle 8">
+            <a:extLst>
+              <a:ext uri="{FF2B5EF4-FFF2-40B4-BE49-F238E27FC236}">
+                <a16:creationId xmlns:a16="http://schemas.microsoft.com/office/drawing/2014/main" id="{1ADE7733-37FF-062C-A580-CE04C748B2A1}"/>
+              </a:ext>
+            </a:extLst>
+          </p:cNvPr>
+          <p:cNvSpPr/>
+          <p:nvPr/>
+        </p:nvSpPr>
+        <p:spPr>
+          <a:xfrm>
+            <a:off x="6126480" y="1417320"/>
+            <a:ext cx="5513832" cy="2377440"/>
+          </a:xfrm>
+          <a:prstGeom prst="rect">
+            <a:avLst/>
+          </a:prstGeom>
+          <a:solidFill>
+            <a:srgbClr val="16161F"/>
+          </a:solidFill>
+          <a:ln w="12700">
+            <a:solidFill>
+              <a:srgbClr val="2A2A38"/>
+            </a:solidFill>
+          </a:ln>
+        </p:spPr>
+        <p:style>
+          <a:lnRef idx="1">
+            <a:schemeClr val="accent1"/>
+          </a:lnRef>
+          <a:fillRef idx="3">
+            <a:schemeClr val="accent1"/>
+          </a:fillRef>
+          <a:effectRef idx="2">
+            <a:schemeClr val="accent1"/>
+          </a:effectRef>
+          <a:fontRef idx="minor">
+            <a:schemeClr val="lt1"/>
+          </a:fontRef>
+        </p:style>
+        <p:txBody>
+          <a:bodyPr rtlCol="0" anchor="ctr"/>
+          <a:lstStyle/>
+          <a:p>
+            <a:pPr algn="ctr"/>
+            <a:endParaRPr/>
+          </a:p>
+        </p:txBody>
+      </p:sp>
+      <p:sp>
+        <p:nvSpPr>
+          <p:cNvPr id="10" name="TextBox 9">
+            <a:extLst>
+              <a:ext uri="{FF2B5EF4-FFF2-40B4-BE49-F238E27FC236}">
+                <a16:creationId xmlns:a16="http://schemas.microsoft.com/office/drawing/2014/main" id="{016F1DA6-2A60-A4EC-3279-9D9E3185E0BE}"/>
+              </a:ext>
+            </a:extLst>
+          </p:cNvPr>
+          <p:cNvSpPr txBox="1"/>
+          <p:nvPr/>
+        </p:nvSpPr>
+        <p:spPr>
+          <a:xfrm>
+            <a:off x="822960" y="4218043"/>
+            <a:ext cx="1340432" cy="276999"/>
+          </a:xfrm>
+          <a:prstGeom prst="rect">
+            <a:avLst/>
+          </a:prstGeom>
+          <a:solidFill>
+            <a:srgbClr val="FF0000"/>
+          </a:solidFill>
+        </p:spPr>
+        <p:txBody>
+          <a:bodyPr wrap="none">
+            <a:spAutoFit/>
+          </a:bodyPr>
+          <a:lstStyle/>
+          <a:p>
+            <a:r>
+              <a:rPr lang="en-US" sz="1200" b="1" dirty="0">
+                <a:solidFill>
+                  <a:schemeClr val="bg1"/>
+                </a:solidFill>
+              </a:rPr>
+              <a:t>CRITICAL FINDING</a:t>
+            </a:r>
+            <a:endParaRPr sz="1200" b="1" dirty="0">
+              <a:solidFill>
+                <a:schemeClr val="bg1"/>
+              </a:solidFill>
+            </a:endParaRPr>
+          </a:p>
+        </p:txBody>
+      </p:sp>
+      <p:sp>
+        <p:nvSpPr>
+          <p:cNvPr id="11" name="TextBox 10">
+            <a:extLst>
+              <a:ext uri="{FF2B5EF4-FFF2-40B4-BE49-F238E27FC236}">
+                <a16:creationId xmlns:a16="http://schemas.microsoft.com/office/drawing/2014/main" id="{CBEA60BC-A198-39EA-A944-505ADCA67E0B}"/>
+              </a:ext>
+            </a:extLst>
+          </p:cNvPr>
+          <p:cNvSpPr txBox="1"/>
+          <p:nvPr/>
+        </p:nvSpPr>
+        <p:spPr>
+          <a:xfrm>
+            <a:off x="777240" y="4675243"/>
+            <a:ext cx="5074920" cy="276999"/>
+          </a:xfrm>
+          <a:prstGeom prst="rect">
+            <a:avLst/>
+          </a:prstGeom>
+          <a:noFill/>
+        </p:spPr>
+        <p:txBody>
+          <a:bodyPr wrap="square">
+            <a:spAutoFit/>
+          </a:bodyPr>
+          <a:lstStyle/>
+          <a:p>
+            <a:pPr>
+              <a:defRPr sz="1200">
+                <a:solidFill>
+                  <a:srgbClr val="FFFFFF"/>
+                </a:solidFill>
+              </a:defRPr>
+            </a:pPr>
+            <a:r>
+              <a:rPr lang="en-US" dirty="0"/>
+              <a:t>P1/P2 defects: P1=1, P2=10 open — run a focused burn-down before release</a:t>
+            </a:r>
+          </a:p>
+          <a:p>
+            <a:pPr>
+              <a:defRPr sz="1200">
+                <a:solidFill>
+                  <a:srgbClr val="FFFFFF"/>
+                </a:solidFill>
+              </a:defRPr>
+            </a:pPr>
+            <a:r>
+              <a:rPr lang="en-US" dirty="0"/>
+              <a:t>Manual P1/P2 execution coverage at 80% — execute remaining tests or formally de-scope with sign-off</a:t>
+            </a:r>
+          </a:p>
+        </p:txBody>
+      </p:sp>
+      <p:sp>
+        <p:nvSpPr>
+          <p:cNvPr id="13" name="TextBox 12">
+            <a:extLst>
+              <a:ext uri="{FF2B5EF4-FFF2-40B4-BE49-F238E27FC236}">
+                <a16:creationId xmlns:a16="http://schemas.microsoft.com/office/drawing/2014/main" id="{1C9E8739-44FF-22EB-6A62-DE37CFD89613}"/>
+              </a:ext>
+            </a:extLst>
+          </p:cNvPr>
+          <p:cNvSpPr txBox="1"/>
+          <p:nvPr/>
+        </p:nvSpPr>
+        <p:spPr>
+          <a:xfrm>
+            <a:off x="777240" y="1619180"/>
+            <a:ext cx="2259336" cy="276999"/>
+          </a:xfrm>
+          <a:prstGeom prst="rect">
+            <a:avLst/>
+          </a:prstGeom>
+          <a:noFill/>
+        </p:spPr>
+        <p:txBody>
+          <a:bodyPr wrap="none">
+            <a:spAutoFit/>
+          </a:bodyPr>
+          <a:lstStyle/>
+          <a:p>
+            <a:r>
+              <a:rPr sz="1200" b="1" dirty="0">
+                <a:solidFill>
+                  <a:srgbClr val="00F6FF"/>
+                </a:solidFill>
+              </a:rPr>
+              <a:t>Conclusion </a:t>
+            </a:r>
+            <a:r>
+              <a:rPr lang="en-US" sz="1200" b="1" dirty="0">
+                <a:solidFill>
+                  <a:srgbClr val="00F6FF"/>
+                </a:solidFill>
+              </a:rPr>
+              <a:t>&amp; Recommendations</a:t>
+            </a:r>
+            <a:endParaRPr sz="1200" b="1" dirty="0">
+              <a:solidFill>
+                <a:srgbClr val="00F6FF"/>
+              </a:solidFill>
+            </a:endParaRPr>
+          </a:p>
+        </p:txBody>
+      </p:sp>
+      <p:sp>
+        <p:nvSpPr>
+          <p:cNvPr id="14" name="TextBox 13">
+            <a:extLst>
+              <a:ext uri="{FF2B5EF4-FFF2-40B4-BE49-F238E27FC236}">
+                <a16:creationId xmlns:a16="http://schemas.microsoft.com/office/drawing/2014/main" id="{FDF81810-FF07-727E-0F67-EA1AEC3AD62F}"/>
+              </a:ext>
+            </a:extLst>
+          </p:cNvPr>
+          <p:cNvSpPr txBox="1"/>
+          <p:nvPr/>
+        </p:nvSpPr>
+        <p:spPr>
+          <a:xfrm>
+            <a:off x="777240" y="1847781"/>
+            <a:ext cx="5120640" cy="276999"/>
+          </a:xfrm>
+          <a:prstGeom prst="rect">
+            <a:avLst/>
+          </a:prstGeom>
+          <a:noFill/>
+        </p:spPr>
+        <p:txBody>
+          <a:bodyPr wrap="square">
+            <a:spAutoFit/>
+          </a:bodyPr>
+          <a:lstStyle/>
+          <a:p>
+            <a:pPr>
+              <a:defRPr sz="1200">
+                <a:solidFill>
+                  <a:srgbClr val="FFFFFF"/>
+                </a:solidFill>
+              </a:defRPr>
+            </a:pPr>
+            <a:r>
+              <a:rPr lang="en-US" dirty="0"/>
+              <a:t>Open P1/P2 defect load and incomplete manual execution coverage are the main blockers to release readiness.</a:t>
+            </a:r>
+            <a:endParaRPr dirty="0"/>
+          </a:p>
+        </p:txBody>
+      </p:sp>
+      <p:sp>
+        <p:nvSpPr>
+          <p:cNvPr id="15" name="Rectangle 14">
+            <a:extLst>
+              <a:ext uri="{FF2B5EF4-FFF2-40B4-BE49-F238E27FC236}">
+                <a16:creationId xmlns:a16="http://schemas.microsoft.com/office/drawing/2014/main" id="{89AE32D8-0530-93B2-DD0B-F9B692CB65B0}"/>
+              </a:ext>
+            </a:extLst>
+          </p:cNvPr>
+          <p:cNvSpPr/>
+          <p:nvPr/>
+        </p:nvSpPr>
+        <p:spPr>
+          <a:xfrm>
+            <a:off x="6126480" y="3977639"/>
+            <a:ext cx="5513832" cy="2560320"/>
+          </a:xfrm>
+          <a:prstGeom prst="rect">
+            <a:avLst/>
+          </a:prstGeom>
+          <a:solidFill>
+            <a:srgbClr val="16161F"/>
+          </a:solidFill>
+          <a:ln w="12700">
+            <a:solidFill>
+              <a:srgbClr val="2A2A38"/>
+            </a:solidFill>
+          </a:ln>
+        </p:spPr>
+        <p:style>
+          <a:lnRef idx="1">
+            <a:schemeClr val="accent1"/>
+          </a:lnRef>
+          <a:fillRef idx="3">
+            <a:schemeClr val="accent1"/>
+          </a:fillRef>
+          <a:effectRef idx="2">
+            <a:schemeClr val="accent1"/>
+          </a:effectRef>
+          <a:fontRef idx="minor">
+            <a:schemeClr val="lt1"/>
+          </a:fontRef>
+        </p:style>
+        <p:txBody>
+          <a:bodyPr rtlCol="0" anchor="ctr"/>
+          <a:lstStyle/>
+          <a:p>
+            <a:pPr algn="ctr"/>
+            <a:endParaRPr/>
+          </a:p>
+        </p:txBody>
+      </p:sp>
+      <p:sp>
+        <p:nvSpPr>
+          <p:cNvPr id="19" name="TextBox 18">
+            <a:extLst>
+              <a:ext uri="{FF2B5EF4-FFF2-40B4-BE49-F238E27FC236}">
+                <a16:creationId xmlns:a16="http://schemas.microsoft.com/office/drawing/2014/main" id="{523A448A-7636-5A7E-9BEB-4650CDC228A0}"/>
+              </a:ext>
+            </a:extLst>
+          </p:cNvPr>
+          <p:cNvSpPr txBox="1"/>
+          <p:nvPr/>
+        </p:nvSpPr>
+        <p:spPr>
+          <a:xfrm>
+            <a:off x="6372519" y="4218043"/>
+            <a:ext cx="1247457" cy="276999"/>
+          </a:xfrm>
+          <a:prstGeom prst="rect">
+            <a:avLst/>
+          </a:prstGeom>
+          <a:solidFill>
+            <a:schemeClr val="accent6">
+              <a:lumMod val="75000"/>
+            </a:schemeClr>
+          </a:solidFill>
+        </p:spPr>
+        <p:txBody>
+          <a:bodyPr wrap="none">
+            <a:spAutoFit/>
+          </a:bodyPr>
+          <a:lstStyle/>
+          <a:p>
+            <a:r>
+              <a:rPr lang="en-US" sz="1200" b="1" dirty="0">
+                <a:solidFill>
+                  <a:schemeClr val="bg1"/>
+                </a:solidFill>
+              </a:rPr>
+              <a:t>AMBER FINDING</a:t>
+            </a:r>
+            <a:endParaRPr sz="1200" b="1" dirty="0">
+              <a:solidFill>
+                <a:schemeClr val="bg1"/>
+              </a:solidFill>
+            </a:endParaRPr>
+          </a:p>
+        </p:txBody>
+      </p:sp>
+      <p:sp>
+        <p:nvSpPr>
+          <p:cNvPr id="21" name="TextBox 20">
+            <a:extLst>
+              <a:ext uri="{FF2B5EF4-FFF2-40B4-BE49-F238E27FC236}">
+                <a16:creationId xmlns:a16="http://schemas.microsoft.com/office/drawing/2014/main" id="{8FE2BCC0-31EA-4A86-6DC7-8CD64F600E11}"/>
+              </a:ext>
+            </a:extLst>
+          </p:cNvPr>
+          <p:cNvSpPr txBox="1"/>
+          <p:nvPr/>
+        </p:nvSpPr>
+        <p:spPr>
+          <a:xfrm>
+            <a:off x="6326799" y="4675243"/>
+            <a:ext cx="5074920" cy="276999"/>
+          </a:xfrm>
+          <a:prstGeom prst="rect">
+            <a:avLst/>
+          </a:prstGeom>
+          <a:noFill/>
+        </p:spPr>
+        <p:txBody>
+          <a:bodyPr wrap="square">
+            <a:spAutoFit/>
+          </a:bodyPr>
+          <a:lstStyle/>
+          <a:p>
+            <a:pPr>
+              <a:defRPr sz="1200">
+                <a:solidFill>
+                  <a:srgbClr val="FFFFFF"/>
+                </a:solidFill>
+              </a:defRPr>
+            </a:pPr>
+            <a:r>
+              <a:rPr lang="en-US" dirty="0"/>
+              <a:t>P3+ defects: 13 open — triage/groom to keep backlog ≤ 10</a:t>
+            </a:r>
+          </a:p>
+          <a:p>
+            <a:pPr>
+              <a:defRPr sz="1200">
+                <a:solidFill>
+                  <a:srgbClr val="FFFFFF"/>
+                </a:solidFill>
+              </a:defRPr>
+            </a:pPr>
+            <a:r>
+              <a:rPr lang="en-US" dirty="0"/>
+              <a:t>Automated P1/P2 execution coverage at 90% — stabilize/fix missing automation to reach 100%</a:t>
+            </a:r>
+          </a:p>
+        </p:txBody>
+      </p:sp>
+      <p:sp>
+        <p:nvSpPr>
+          <p:cNvPr id="22" name="TextBox 21">
+            <a:extLst>
+              <a:ext uri="{FF2B5EF4-FFF2-40B4-BE49-F238E27FC236}">
+                <a16:creationId xmlns:a16="http://schemas.microsoft.com/office/drawing/2014/main" id="{215E1FEB-C253-66A3-13ED-A8A896449369}"/>
+              </a:ext>
+            </a:extLst>
+          </p:cNvPr>
+          <p:cNvSpPr txBox="1"/>
+          <p:nvPr/>
+        </p:nvSpPr>
+        <p:spPr>
+          <a:xfrm>
+            <a:off x="6300216" y="1539003"/>
+            <a:ext cx="4937760" cy="320040"/>
+          </a:xfrm>
+          <a:prstGeom prst="rect">
+            <a:avLst/>
+          </a:prstGeom>
+          <a:noFill/>
+        </p:spPr>
+        <p:txBody>
+          <a:bodyPr wrap="none">
+            <a:spAutoFit/>
+          </a:bodyPr>
+          <a:lstStyle/>
+          <a:p>
+            <a:r>
+              <a:rPr sz="1200" b="1">
+                <a:solidFill>
+                  <a:srgbClr val="00F6FF"/>
+                </a:solidFill>
+              </a:rPr>
+              <a:t>Key data</a:t>
+            </a:r>
+          </a:p>
+        </p:txBody>
+      </p:sp>
+      <p:graphicFrame>
+        <p:nvGraphicFramePr>
+          <p:cNvPr id="24" name="Table 23">
+            <a:extLst>
+              <a:ext uri="{FF2B5EF4-FFF2-40B4-BE49-F238E27FC236}">
+                <a16:creationId xmlns:a16="http://schemas.microsoft.com/office/drawing/2014/main" id="{C22669FE-A7B9-2838-1241-7B81E7C566E7}"/>
+              </a:ext>
+            </a:extLst>
+          </p:cNvPr>
+          <p:cNvGraphicFramePr>
+            <a:graphicFrameLocks noGrp="1"/>
+          </p:cNvGraphicFramePr>
+          <p:nvPr>
+            <p:extLst>
+              <p:ext uri="{D42A27DB-BD31-4B8C-83A1-F6EECF244321}">
+                <p14:modId xmlns:p14="http://schemas.microsoft.com/office/powerpoint/2010/main" val="1735270760"/>
+              </p:ext>
+            </p:extLst>
+          </p:nvPr>
+        </p:nvGraphicFramePr>
+        <p:xfrm>
+          <a:off x="6300216" y="1848883"/>
+          <a:ext cx="4937760" cy="1926336"/>
+        </p:xfrm>
+        <a:graphic>
+          <a:graphicData uri="http://schemas.openxmlformats.org/drawingml/2006/table">
+            <a:tbl>
+              <a:tblPr firstRow="1" bandRow="1">
+                <a:tableStyleId>{5C22544A-7EE6-4342-B048-85BDC9FD1C3A}</a:tableStyleId>
+              </a:tblPr>
+              <a:tblGrid>
+                <a:gridCol w="2221992">
+                  <a:extLst>
+                    <a:ext uri="{9D8B030D-6E8A-4147-A177-3AD203B41FA5}">
+                      <a16:colId xmlns:a16="http://schemas.microsoft.com/office/drawing/2014/main" val="20000"/>
+                    </a:ext>
+                  </a:extLst>
+                </a:gridCol>
+                <a:gridCol w="2715768">
+                  <a:extLst>
+                    <a:ext uri="{9D8B030D-6E8A-4147-A177-3AD203B41FA5}">
+                      <a16:colId xmlns:a16="http://schemas.microsoft.com/office/drawing/2014/main" val="20001"/>
+                    </a:ext>
+                  </a:extLst>
+                </a:gridCol>
+              </a:tblGrid>
+              <a:tr h="374903">
+                <a:tc>
+                  <a:txBody>
+                    <a:bodyPr/>
+                    <a:lstStyle/>
+                    <a:p>
+                      <a:r>
+                        <a:rPr sz="1200" b="1">
+                          <a:solidFill>
+                            <a:srgbClr val="00F6FF"/>
+                          </a:solidFill>
+                        </a:rPr>
+                        <a:t>Key data</a:t>
+                      </a:r>
+                    </a:p>
+                  </a:txBody>
+                  <a:tcPr>
+                    <a:solidFill>
+                      <a:srgbClr val="1F1F2B"/>
+                    </a:solidFill>
+                  </a:tcPr>
+                </a:tc>
+                <a:tc>
+                  <a:txBody>
+                    <a:bodyPr/>
+                    <a:lstStyle/>
+                    <a:p>
+                      <a:r>
+                        <a:rPr sz="1200" b="1">
+                          <a:solidFill>
+                            <a:srgbClr val="00F6FF"/>
+                          </a:solidFill>
+                        </a:rPr>
+                        <a:t>Value</a:t>
+                      </a:r>
+                    </a:p>
+                  </a:txBody>
+                  <a:tcPr>
+                    <a:solidFill>
+                      <a:srgbClr val="1F1F2B"/>
+                    </a:solidFill>
+                  </a:tcPr>
+                </a:tc>
+                <a:extLst>
+                  <a:ext uri="{0D108BD9-81ED-4DB2-BD59-A6C34878D82A}">
+                    <a16:rowId xmlns:a16="http://schemas.microsoft.com/office/drawing/2014/main" val="10000"/>
+                  </a:ext>
+                </a:extLst>
+              </a:tr>
+              <a:tr h="374903">
+                <a:tc>
+                  <a:txBody>
+                    <a:bodyPr/>
+                    <a:lstStyle/>
+                    <a:p>
+                      <a:r>
+                        <a:rPr lang="en-US" sz="1100" dirty="0">
+                          <a:solidFill>
+                            <a:srgbClr val="FFFFFF"/>
+                          </a:solidFill>
+                        </a:rPr>
+                        <a:t>Open defects P1/P2</a:t>
+                      </a:r>
+                      <a:endParaRPr sz="1100" dirty="0">
+                        <a:solidFill>
+                          <a:srgbClr val="FFFFFF"/>
+                        </a:solidFill>
+                      </a:endParaRPr>
+                    </a:p>
+                  </a:txBody>
+                  <a:tcPr>
+                    <a:solidFill>
+                      <a:srgbClr val="16161F"/>
+                    </a:solidFill>
+                  </a:tcPr>
+                </a:tc>
+                <a:tc>
+                  <a:txBody>
+                    <a:bodyPr/>
+                    <a:lstStyle/>
+                    <a:p>
+                      <a:r>
+                        <a:rPr lang="en-US" sz="1100" dirty="0">
+                          <a:solidFill>
+                            <a:srgbClr val="FFFFFF"/>
+                          </a:solidFill>
+                        </a:rPr>
+                        <a:t>P1=1, P2=10</a:t>
+                      </a:r>
+                      <a:endParaRPr sz="1100" dirty="0">
+                        <a:solidFill>
+                          <a:srgbClr val="FFFFFF"/>
+                        </a:solidFill>
+                      </a:endParaRPr>
+                    </a:p>
+                  </a:txBody>
+                  <a:tcPr>
+                    <a:solidFill>
+                      <a:srgbClr val="16161F"/>
+                    </a:solidFill>
+                  </a:tcPr>
+                </a:tc>
+                <a:extLst>
+                  <a:ext uri="{0D108BD9-81ED-4DB2-BD59-A6C34878D82A}">
+                    <a16:rowId xmlns:a16="http://schemas.microsoft.com/office/drawing/2014/main" val="10001"/>
+                  </a:ext>
+                </a:extLst>
+              </a:tr>
+              <a:tr h="374903">
+                <a:tc>
+                  <a:txBody>
+                    <a:bodyPr/>
+                    <a:lstStyle/>
+                    <a:p>
+                      <a:r>
+                        <a:rPr lang="en-US" sz="1100" dirty="0">
+                          <a:solidFill>
+                            <a:srgbClr val="FFFFFF"/>
+                          </a:solidFill>
+                        </a:rPr>
+                        <a:t>Manual P1/P2 execution coverage</a:t>
+                      </a:r>
+                      <a:endParaRPr sz="1100" dirty="0">
+                        <a:solidFill>
+                          <a:srgbClr val="FFFFFF"/>
+                        </a:solidFill>
+                      </a:endParaRPr>
+                    </a:p>
+                  </a:txBody>
+                  <a:tcPr>
+                    <a:solidFill>
+                      <a:srgbClr val="16161F"/>
+                    </a:solidFill>
+                  </a:tcPr>
+                </a:tc>
+                <a:tc>
+                  <a:txBody>
+                    <a:bodyPr/>
+                    <a:lstStyle/>
+                    <a:p>
+                      <a:r>
+                        <a:rPr lang="en-US" sz="1100" dirty="0">
+                          <a:solidFill>
+                            <a:srgbClr val="FFFFFF"/>
+                          </a:solidFill>
+                        </a:rPr>
+                        <a:t>80%</a:t>
+                      </a:r>
+                      <a:endParaRPr sz="1100" dirty="0">
+                        <a:solidFill>
+                          <a:srgbClr val="FFFFFF"/>
+                        </a:solidFill>
+                      </a:endParaRPr>
+                    </a:p>
+                  </a:txBody>
+                  <a:tcPr>
+                    <a:solidFill>
+                      <a:srgbClr val="16161F"/>
+                    </a:solidFill>
+                  </a:tcPr>
+                </a:tc>
+                <a:extLst>
+                  <a:ext uri="{0D108BD9-81ED-4DB2-BD59-A6C34878D82A}">
+                    <a16:rowId xmlns:a16="http://schemas.microsoft.com/office/drawing/2014/main" val="10002"/>
+                  </a:ext>
+                </a:extLst>
+              </a:tr>
+              <a:tr h="374903">
+                <a:tc>
+                  <a:txBody>
+                    <a:bodyPr/>
+                    <a:lstStyle/>
+                    <a:p>
+                      <a:pPr marL="0" marR="0" lvl="0" indent="0" algn="l" defTabSz="914400" rtl="0" eaLnBrk="1" fontAlgn="auto" latinLnBrk="0" hangingPunct="1">
+                        <a:lnSpc>
+                          <a:spcPct val="100000"/>
+                        </a:lnSpc>
+                        <a:spcBef>
+                          <a:spcPts val="0"/>
+                        </a:spcBef>
+                        <a:spcAft>
+                          <a:spcPts val="0"/>
+                        </a:spcAft>
+                        <a:buClrTx/>
+                        <a:buSzTx/>
+                        <a:buFontTx/>
+                        <a:buNone/>
+                        <a:tabLst/>
+                        <a:defRPr/>
+                      </a:pPr>
+                      <a:r>
+                        <a:rPr lang="en-US" sz="1100" dirty="0">
+                          <a:solidFill>
+                            <a:srgbClr val="FFFFFF"/>
+                          </a:solidFill>
+                        </a:rPr>
+                        <a:t>Open defects P3+</a:t>
+                      </a:r>
+                    </a:p>
+                    <a:p>
+                      <a:endParaRPr sz="1100" dirty="0">
+                        <a:solidFill>
+                          <a:srgbClr val="FFFFFF"/>
+                        </a:solidFill>
+                      </a:endParaRPr>
+                    </a:p>
+                  </a:txBody>
+                  <a:tcPr>
+                    <a:solidFill>
+                      <a:srgbClr val="16161F"/>
+                    </a:solidFill>
+                  </a:tcPr>
+                </a:tc>
+                <a:tc>
+                  <a:txBody>
+                    <a:bodyPr/>
+                    <a:lstStyle/>
+                    <a:p>
+                      <a:pPr marL="0" marR="0" lvl="0" indent="0" algn="l" defTabSz="914400" rtl="0" eaLnBrk="1" fontAlgn="auto" latinLnBrk="0" hangingPunct="1">
+                        <a:lnSpc>
+                          <a:spcPct val="100000"/>
+                        </a:lnSpc>
+                        <a:spcBef>
+                          <a:spcPts val="0"/>
+                        </a:spcBef>
+                        <a:spcAft>
+                          <a:spcPts val="0"/>
+                        </a:spcAft>
+                        <a:buClrTx/>
+                        <a:buSzTx/>
+                        <a:buFontTx/>
+                        <a:buNone/>
+                        <a:tabLst/>
+                        <a:defRPr/>
+                      </a:pPr>
+                      <a:r>
+                        <a:rPr lang="en-US" sz="1100" dirty="0">
+                          <a:solidFill>
+                            <a:srgbClr val="FFFFFF"/>
+                          </a:solidFill>
+                        </a:rPr>
+                        <a:t>13</a:t>
+                      </a:r>
+                    </a:p>
+                  </a:txBody>
+                  <a:tcPr>
+                    <a:solidFill>
+                      <a:srgbClr val="16161F"/>
+                    </a:solidFill>
+                  </a:tcPr>
+                </a:tc>
+                <a:extLst>
+                  <a:ext uri="{0D108BD9-81ED-4DB2-BD59-A6C34878D82A}">
+                    <a16:rowId xmlns:a16="http://schemas.microsoft.com/office/drawing/2014/main" val="10003"/>
+                  </a:ext>
+                </a:extLst>
+              </a:tr>
+              <a:tr h="374907">
+                <a:tc>
+                  <a:txBody>
+                    <a:bodyPr/>
+                    <a:lstStyle/>
+                    <a:p>
+                      <a:pPr marL="0" marR="0" lvl="0" indent="0" algn="l" defTabSz="914400" rtl="0" eaLnBrk="1" fontAlgn="auto" latinLnBrk="0" hangingPunct="1">
+                        <a:lnSpc>
+                          <a:spcPct val="100000"/>
+                        </a:lnSpc>
+                        <a:spcBef>
+                          <a:spcPts val="0"/>
+                        </a:spcBef>
+                        <a:spcAft>
+                          <a:spcPts val="0"/>
+                        </a:spcAft>
+                        <a:buClrTx/>
+                        <a:buSzTx/>
+                        <a:buFontTx/>
+                        <a:buNone/>
+                        <a:tabLst/>
+                        <a:defRPr/>
+                      </a:pPr>
+                      <a:r>
+                        <a:rPr lang="en-US" sz="1100" dirty="0">
+                          <a:solidFill>
+                            <a:srgbClr val="FFFFFF"/>
+                          </a:solidFill>
+                        </a:rPr>
+                        <a:t>Automated P1/P2 execution coverage</a:t>
+                      </a:r>
+                    </a:p>
+                  </a:txBody>
+                  <a:tcPr>
+                    <a:solidFill>
+                      <a:srgbClr val="16161F"/>
+                    </a:solidFill>
+                  </a:tcPr>
+                </a:tc>
+                <a:tc>
+                  <a:txBody>
+                    <a:bodyPr/>
+                    <a:lstStyle/>
+                    <a:p>
+                      <a:pPr marL="0" marR="0" lvl="0" indent="0" algn="l" defTabSz="914400" rtl="0" eaLnBrk="1" fontAlgn="auto" latinLnBrk="0" hangingPunct="1">
+                        <a:lnSpc>
+                          <a:spcPct val="100000"/>
+                        </a:lnSpc>
+                        <a:spcBef>
+                          <a:spcPts val="0"/>
+                        </a:spcBef>
+                        <a:spcAft>
+                          <a:spcPts val="0"/>
+                        </a:spcAft>
+                        <a:buClrTx/>
+                        <a:buSzTx/>
+                        <a:buFontTx/>
+                        <a:buNone/>
+                        <a:tabLst/>
+                        <a:defRPr/>
+                      </a:pPr>
+                      <a:r>
+                        <a:rPr lang="en-US" sz="1100" dirty="0">
+                          <a:solidFill>
+                            <a:srgbClr val="FFFFFF"/>
+                          </a:solidFill>
+                        </a:rPr>
+                        <a:t>90%</a:t>
                       </a:r>
                     </a:p>
                   </a:txBody>

</xml_diff>